<commit_message>
ppt vegleges es eloadoi szoveg
</commit_message>
<xml_diff>
--- a/Horror_FPS_Egyszerusitett  -  Kijavítva.pptx
+++ b/Horror_FPS_Egyszerusitett  -  Kijavítva.pptx
@@ -2061,7 +2061,7 @@
               </a:lnSpc>
             </a:pPr>
             <a:r>
-              <a:rPr lang="en-US" sz="2600" b="1" dirty="0">
+              <a:rPr lang="hu-HU" sz="2600" b="1" dirty="0">
                 <a:solidFill>
                   <a:srgbClr val="263238"/>
                 </a:solidFill>
@@ -2069,7 +2069,18 @@
                 <a:ea typeface="Sorts Mill Goudy" pitchFamily="34" charset="-122"/>
                 <a:cs typeface="Sorts Mill Goudy" pitchFamily="34" charset="-120"/>
               </a:rPr>
-              <a:t>Menürendszer három móddal és 60 FPS-es game loop biztosítja a folyamatos élményt</a:t>
+              <a:t>A </a:t>
+            </a:r>
+            <a:r>
+              <a:rPr lang="hu-HU" sz="2600" b="1" dirty="0" err="1">
+                <a:solidFill>
+                  <a:srgbClr val="263238"/>
+                </a:solidFill>
+                <a:latin typeface="Sorts Mill Goudy" pitchFamily="34" charset="0"/>
+                <a:ea typeface="Sorts Mill Goudy" pitchFamily="34" charset="-122"/>
+                <a:cs typeface="Sorts Mill Goudy" pitchFamily="34" charset="-120"/>
+              </a:rPr>
+              <a:t>game_state</a:t>
             </a:r>
             <a:endParaRPr lang="en-US" sz="1600" dirty="0"/>
           </a:p>
@@ -2361,9 +2372,58 @@
                 <a:ea typeface="Liter" pitchFamily="34" charset="-122"/>
                 <a:cs typeface="Liter" pitchFamily="34" charset="-120"/>
               </a:rPr>
-              <a:t>1. screen.fill() háttér törlés</a:t>
-            </a:r>
-            <a:endParaRPr lang="en-US" sz="1600" dirty="0"/>
+              <a:t>1. screen.fill() </a:t>
+            </a:r>
+            <a:r>
+              <a:rPr lang="hu-HU" sz="1600" dirty="0">
+                <a:solidFill>
+                  <a:schemeClr val="tx1">
+                    <a:lumMod val="65000"/>
+                    <a:lumOff val="35000"/>
+                  </a:schemeClr>
+                </a:solidFill>
+                <a:latin typeface="Liter" pitchFamily="34" charset="0"/>
+                <a:ea typeface="Liter" pitchFamily="34" charset="-122"/>
+                <a:cs typeface="Liter" pitchFamily="34" charset="-120"/>
+              </a:rPr>
+              <a:t>- </a:t>
+            </a:r>
+            <a:r>
+              <a:rPr lang="en-US" sz="1600" dirty="0" err="1">
+                <a:solidFill>
+                  <a:schemeClr val="tx1">
+                    <a:lumMod val="65000"/>
+                    <a:lumOff val="35000"/>
+                  </a:schemeClr>
+                </a:solidFill>
+                <a:latin typeface="Liter" pitchFamily="34" charset="0"/>
+                <a:ea typeface="Liter" pitchFamily="34" charset="-122"/>
+                <a:cs typeface="Liter" pitchFamily="34" charset="-120"/>
+              </a:rPr>
+              <a:t>háttér</a:t>
+            </a:r>
+            <a:r>
+              <a:rPr lang="en-US" sz="1600" dirty="0">
+                <a:solidFill>
+                  <a:schemeClr val="tx1">
+                    <a:lumMod val="65000"/>
+                    <a:lumOff val="35000"/>
+                  </a:schemeClr>
+                </a:solidFill>
+                <a:latin typeface="Liter" pitchFamily="34" charset="0"/>
+                <a:ea typeface="Liter" pitchFamily="34" charset="-122"/>
+                <a:cs typeface="Liter" pitchFamily="34" charset="-120"/>
+              </a:rPr>
+              <a:t> törlés</a:t>
+            </a:r>
+            <a:endParaRPr lang="en-US" sz="1600" dirty="0">
+              <a:solidFill>
+                <a:schemeClr val="tx1">
+                  <a:lumMod val="65000"/>
+                  <a:lumOff val="35000"/>
+                </a:schemeClr>
+              </a:solidFill>
+            </a:endParaRPr>
           </a:p>
           <a:p>
             <a:pPr>
@@ -2380,7 +2440,40 @@
                 <a:ea typeface="Liter" pitchFamily="34" charset="-122"/>
                 <a:cs typeface="Liter" pitchFamily="34" charset="-120"/>
               </a:rPr>
-              <a:t>2. Ég (70,120,200) + föld (50,50,50)</a:t>
+              <a:t>2. </a:t>
+            </a:r>
+            <a:r>
+              <a:rPr lang="en-US" sz="1600" dirty="0" err="1">
+                <a:solidFill>
+                  <a:srgbClr val="333333"/>
+                </a:solidFill>
+                <a:latin typeface="Liter" pitchFamily="34" charset="0"/>
+                <a:ea typeface="Liter" pitchFamily="34" charset="-122"/>
+                <a:cs typeface="Liter" pitchFamily="34" charset="-120"/>
+              </a:rPr>
+              <a:t>Ég</a:t>
+            </a:r>
+            <a:r>
+              <a:rPr lang="en-US" sz="1600" dirty="0">
+                <a:solidFill>
+                  <a:srgbClr val="333333"/>
+                </a:solidFill>
+                <a:latin typeface="Liter" pitchFamily="34" charset="0"/>
+                <a:ea typeface="Liter" pitchFamily="34" charset="-122"/>
+                <a:cs typeface="Liter" pitchFamily="34" charset="-120"/>
+              </a:rPr>
+              <a:t> + </a:t>
+            </a:r>
+            <a:r>
+              <a:rPr lang="en-US" sz="1600" dirty="0" err="1">
+                <a:solidFill>
+                  <a:srgbClr val="333333"/>
+                </a:solidFill>
+                <a:latin typeface="Liter" pitchFamily="34" charset="0"/>
+                <a:ea typeface="Liter" pitchFamily="34" charset="-122"/>
+                <a:cs typeface="Liter" pitchFamily="34" charset="-120"/>
+              </a:rPr>
+              <a:t>föld</a:t>
             </a:r>
             <a:endParaRPr lang="en-US" sz="1600" dirty="0"/>
           </a:p>
@@ -2399,9 +2492,58 @@
                 <a:ea typeface="Liter" pitchFamily="34" charset="-122"/>
                 <a:cs typeface="Liter" pitchFamily="34" charset="-120"/>
               </a:rPr>
-              <a:t>3. cast_rays() falak és ajtók</a:t>
-            </a:r>
-            <a:endParaRPr lang="en-US" sz="1600" dirty="0"/>
+              <a:t>3. cast_rays() </a:t>
+            </a:r>
+            <a:r>
+              <a:rPr lang="hu-HU" sz="1600" dirty="0">
+                <a:solidFill>
+                  <a:schemeClr val="tx1">
+                    <a:lumMod val="65000"/>
+                    <a:lumOff val="35000"/>
+                  </a:schemeClr>
+                </a:solidFill>
+                <a:latin typeface="Liter" pitchFamily="34" charset="0"/>
+                <a:ea typeface="Liter" pitchFamily="34" charset="-122"/>
+                <a:cs typeface="Liter" pitchFamily="34" charset="-120"/>
+              </a:rPr>
+              <a:t>- </a:t>
+            </a:r>
+            <a:r>
+              <a:rPr lang="en-US" sz="1600" dirty="0" err="1">
+                <a:solidFill>
+                  <a:schemeClr val="tx1">
+                    <a:lumMod val="65000"/>
+                    <a:lumOff val="35000"/>
+                  </a:schemeClr>
+                </a:solidFill>
+                <a:latin typeface="Liter" pitchFamily="34" charset="0"/>
+                <a:ea typeface="Liter" pitchFamily="34" charset="-122"/>
+                <a:cs typeface="Liter" pitchFamily="34" charset="-120"/>
+              </a:rPr>
+              <a:t>falak</a:t>
+            </a:r>
+            <a:r>
+              <a:rPr lang="en-US" sz="1600" dirty="0">
+                <a:solidFill>
+                  <a:schemeClr val="tx1">
+                    <a:lumMod val="65000"/>
+                    <a:lumOff val="35000"/>
+                  </a:schemeClr>
+                </a:solidFill>
+                <a:latin typeface="Liter" pitchFamily="34" charset="0"/>
+                <a:ea typeface="Liter" pitchFamily="34" charset="-122"/>
+                <a:cs typeface="Liter" pitchFamily="34" charset="-120"/>
+              </a:rPr>
+              <a:t> és ajtók</a:t>
+            </a:r>
+            <a:endParaRPr lang="en-US" sz="1600" dirty="0">
+              <a:solidFill>
+                <a:schemeClr val="tx1">
+                  <a:lumMod val="65000"/>
+                  <a:lumOff val="35000"/>
+                </a:schemeClr>
+              </a:solidFill>
+            </a:endParaRPr>
           </a:p>
           <a:p>
             <a:pPr>
@@ -2418,9 +2560,44 @@
                 <a:ea typeface="Liter" pitchFamily="34" charset="-122"/>
                 <a:cs typeface="Liter" pitchFamily="34" charset="-120"/>
               </a:rPr>
-              <a:t>4. check_locked_doors() ajtófeloldás</a:t>
-            </a:r>
-            <a:endParaRPr lang="en-US" sz="1600" dirty="0"/>
+              <a:t>4. check_locked_doors() </a:t>
+            </a:r>
+            <a:r>
+              <a:rPr lang="hu-HU" sz="1600" dirty="0">
+                <a:solidFill>
+                  <a:schemeClr val="tx1">
+                    <a:lumMod val="65000"/>
+                    <a:lumOff val="35000"/>
+                  </a:schemeClr>
+                </a:solidFill>
+                <a:latin typeface="Liter" pitchFamily="34" charset="0"/>
+                <a:ea typeface="Liter" pitchFamily="34" charset="-122"/>
+                <a:cs typeface="Liter" pitchFamily="34" charset="-120"/>
+              </a:rPr>
+              <a:t>- </a:t>
+            </a:r>
+            <a:r>
+              <a:rPr lang="en-US" sz="1600" dirty="0" err="1">
+                <a:solidFill>
+                  <a:schemeClr val="tx1">
+                    <a:lumMod val="65000"/>
+                    <a:lumOff val="35000"/>
+                  </a:schemeClr>
+                </a:solidFill>
+                <a:latin typeface="Liter" pitchFamily="34" charset="0"/>
+                <a:ea typeface="Liter" pitchFamily="34" charset="-122"/>
+                <a:cs typeface="Liter" pitchFamily="34" charset="-120"/>
+              </a:rPr>
+              <a:t>ajtófeloldás</a:t>
+            </a:r>
+            <a:endParaRPr lang="en-US" sz="1600" dirty="0">
+              <a:solidFill>
+                <a:schemeClr val="tx1">
+                  <a:lumMod val="65000"/>
+                  <a:lumOff val="35000"/>
+                </a:schemeClr>
+              </a:solidFill>
+            </a:endParaRPr>
           </a:p>
           <a:p>
             <a:pPr>
@@ -5342,7 +5519,29 @@
                 <a:ea typeface="Sorts Mill Goudy" pitchFamily="34" charset="-122"/>
                 <a:cs typeface="Sorts Mill Goudy" pitchFamily="34" charset="-120"/>
               </a:rPr>
-              <a:t>A raycasting motor valós idejű 3D-síkbelítést biztosít DDA algoritmussal</a:t>
+              <a:t>A </a:t>
+            </a:r>
+            <a:r>
+              <a:rPr lang="en-US" sz="2600" b="1" dirty="0" err="1">
+                <a:solidFill>
+                  <a:srgbClr val="263238"/>
+                </a:solidFill>
+                <a:latin typeface="Sorts Mill Goudy" pitchFamily="34" charset="0"/>
+                <a:ea typeface="Sorts Mill Goudy" pitchFamily="34" charset="-122"/>
+                <a:cs typeface="Sorts Mill Goudy" pitchFamily="34" charset="-120"/>
+              </a:rPr>
+              <a:t>raycasting</a:t>
+            </a:r>
+            <a:r>
+              <a:rPr lang="en-US" sz="2600" b="1" dirty="0">
+                <a:solidFill>
+                  <a:srgbClr val="263238"/>
+                </a:solidFill>
+                <a:latin typeface="Sorts Mill Goudy" pitchFamily="34" charset="0"/>
+                <a:ea typeface="Sorts Mill Goudy" pitchFamily="34" charset="-122"/>
+                <a:cs typeface="Sorts Mill Goudy" pitchFamily="34" charset="-120"/>
+              </a:rPr>
+              <a:t> motor</a:t>
             </a:r>
             <a:endParaRPr lang="en-US" sz="1600" dirty="0"/>
           </a:p>
@@ -5506,7 +5705,73 @@
                 <a:ea typeface="Liter" pitchFamily="34" charset="-122"/>
                 <a:cs typeface="Liter" pitchFamily="34" charset="-120"/>
               </a:rPr>
-              <a:t> 1=fal (bwall.png), 2=ajtó (wood_door_01.png), 3=zárolt (locked_door.png).</a:t>
+              <a:t> 1=</a:t>
+            </a:r>
+            <a:r>
+              <a:rPr lang="en-US" sz="1800" dirty="0" err="1">
+                <a:solidFill>
+                  <a:srgbClr val="333333"/>
+                </a:solidFill>
+                <a:latin typeface="Liter" pitchFamily="34" charset="0"/>
+                <a:ea typeface="Liter" pitchFamily="34" charset="-122"/>
+                <a:cs typeface="Liter" pitchFamily="34" charset="-120"/>
+              </a:rPr>
+              <a:t>fal</a:t>
+            </a:r>
+            <a:r>
+              <a:rPr lang="en-US" sz="1800" dirty="0">
+                <a:solidFill>
+                  <a:srgbClr val="333333"/>
+                </a:solidFill>
+                <a:latin typeface="Liter" pitchFamily="34" charset="0"/>
+                <a:ea typeface="Liter" pitchFamily="34" charset="-122"/>
+                <a:cs typeface="Liter" pitchFamily="34" charset="-120"/>
+              </a:rPr>
+              <a:t>, 2=</a:t>
+            </a:r>
+            <a:r>
+              <a:rPr lang="en-US" sz="1800" dirty="0" err="1">
+                <a:solidFill>
+                  <a:srgbClr val="333333"/>
+                </a:solidFill>
+                <a:latin typeface="Liter" pitchFamily="34" charset="0"/>
+                <a:ea typeface="Liter" pitchFamily="34" charset="-122"/>
+                <a:cs typeface="Liter" pitchFamily="34" charset="-120"/>
+              </a:rPr>
+              <a:t>ajtó</a:t>
+            </a:r>
+            <a:r>
+              <a:rPr lang="en-US" sz="1800" dirty="0">
+                <a:solidFill>
+                  <a:srgbClr val="333333"/>
+                </a:solidFill>
+                <a:latin typeface="Liter" pitchFamily="34" charset="0"/>
+                <a:ea typeface="Liter" pitchFamily="34" charset="-122"/>
+                <a:cs typeface="Liter" pitchFamily="34" charset="-120"/>
+              </a:rPr>
+              <a:t>, 3=</a:t>
+            </a:r>
+            <a:r>
+              <a:rPr lang="en-US" sz="1800" dirty="0" err="1">
+                <a:solidFill>
+                  <a:srgbClr val="333333"/>
+                </a:solidFill>
+                <a:latin typeface="Liter" pitchFamily="34" charset="0"/>
+                <a:ea typeface="Liter" pitchFamily="34" charset="-122"/>
+                <a:cs typeface="Liter" pitchFamily="34" charset="-120"/>
+              </a:rPr>
+              <a:t>zárolt</a:t>
+            </a:r>
+            <a:r>
+              <a:rPr lang="en-US" sz="1800" dirty="0">
+                <a:solidFill>
+                  <a:srgbClr val="333333"/>
+                </a:solidFill>
+                <a:latin typeface="Liter" pitchFamily="34" charset="0"/>
+                <a:ea typeface="Liter" pitchFamily="34" charset="-122"/>
+                <a:cs typeface="Liter" pitchFamily="34" charset="-120"/>
+              </a:rPr>
+              <a:t>.</a:t>
             </a:r>
             <a:endParaRPr lang="en-US" sz="1600" dirty="0"/>
           </a:p>
@@ -5536,7 +5801,7 @@
                 <a:ea typeface="Liter" pitchFamily="34" charset="-122"/>
                 <a:cs typeface="Liter" pitchFamily="34" charset="-120"/>
               </a:rPr>
-              <a:t> FOV=π/3 (60°), 720×480 felbontás, 60 FPS cél.</a:t>
+              <a:t> FOV=60°, 720×480 felbontás, 60 FPS cél.</a:t>
             </a:r>
             <a:endParaRPr lang="en-US" sz="1600" dirty="0"/>
           </a:p>
@@ -6048,7 +6313,29 @@
                 <a:ea typeface="Sorts Mill Goudy" pitchFamily="34" charset="-122"/>
                 <a:cs typeface="Sorts Mill Goudy" pitchFamily="34" charset="-120"/>
               </a:rPr>
-              <a:t>A 18×12-es NumPy pálya három szintes struktúrát és progresszív nehézséget biztosít</a:t>
+              <a:t>A </a:t>
+            </a:r>
+            <a:r>
+              <a:rPr lang="hu-HU" sz="2600" b="1" dirty="0" err="1">
+                <a:solidFill>
+                  <a:srgbClr val="263238"/>
+                </a:solidFill>
+                <a:latin typeface="Sorts Mill Goudy" pitchFamily="34" charset="0"/>
+                <a:ea typeface="Sorts Mill Goudy" pitchFamily="34" charset="-122"/>
+                <a:cs typeface="Sorts Mill Goudy" pitchFamily="34" charset="-120"/>
+              </a:rPr>
+              <a:t>Numpy</a:t>
+            </a:r>
+            <a:r>
+              <a:rPr lang="hu-HU" sz="2600" b="1" dirty="0">
+                <a:solidFill>
+                  <a:srgbClr val="263238"/>
+                </a:solidFill>
+                <a:latin typeface="Sorts Mill Goudy" pitchFamily="34" charset="0"/>
+                <a:ea typeface="Sorts Mill Goudy" pitchFamily="34" charset="-122"/>
+                <a:cs typeface="Sorts Mill Goudy" pitchFamily="34" charset="-120"/>
+              </a:rPr>
+              <a:t> pálya</a:t>
             </a:r>
             <a:endParaRPr lang="en-US" sz="1600" dirty="0"/>
           </a:p>
@@ -8686,7 +8973,7 @@
               </a:lnSpc>
             </a:pPr>
             <a:r>
-              <a:rPr lang="en-US" sz="2600" b="1" dirty="0">
+              <a:rPr lang="hu-HU" sz="2600" b="1" dirty="0">
                 <a:solidFill>
                   <a:srgbClr val="263238"/>
                 </a:solidFill>
@@ -8694,7 +8981,51 @@
                 <a:ea typeface="Sorts Mill Goudy" pitchFamily="34" charset="-122"/>
                 <a:cs typeface="Sorts Mill Goudy" pitchFamily="34" charset="-120"/>
               </a:rPr>
-              <a:t>Hét egyedi ellenség progresszív HP-értékekkel és sprite-alapú megjelenítéssel</a:t>
+              <a:t>E</a:t>
+            </a:r>
+            <a:r>
+              <a:rPr lang="en-US" sz="2600" b="1" dirty="0" err="1">
+                <a:solidFill>
+                  <a:srgbClr val="263238"/>
+                </a:solidFill>
+                <a:latin typeface="Sorts Mill Goudy" pitchFamily="34" charset="0"/>
+                <a:ea typeface="Sorts Mill Goudy" pitchFamily="34" charset="-122"/>
+                <a:cs typeface="Sorts Mill Goudy" pitchFamily="34" charset="-120"/>
+              </a:rPr>
+              <a:t>gyedi</a:t>
+            </a:r>
+            <a:r>
+              <a:rPr lang="en-US" sz="2600" b="1" dirty="0">
+                <a:solidFill>
+                  <a:srgbClr val="263238"/>
+                </a:solidFill>
+                <a:latin typeface="Sorts Mill Goudy" pitchFamily="34" charset="0"/>
+                <a:ea typeface="Sorts Mill Goudy" pitchFamily="34" charset="-122"/>
+                <a:cs typeface="Sorts Mill Goudy" pitchFamily="34" charset="-120"/>
+              </a:rPr>
+              <a:t> </a:t>
+            </a:r>
+            <a:r>
+              <a:rPr lang="en-US" sz="2600" b="1" dirty="0" err="1">
+                <a:solidFill>
+                  <a:srgbClr val="263238"/>
+                </a:solidFill>
+                <a:latin typeface="Sorts Mill Goudy" pitchFamily="34" charset="0"/>
+                <a:ea typeface="Sorts Mill Goudy" pitchFamily="34" charset="-122"/>
+                <a:cs typeface="Sorts Mill Goudy" pitchFamily="34" charset="-120"/>
+              </a:rPr>
+              <a:t>ellenség</a:t>
+            </a:r>
+            <a:r>
+              <a:rPr lang="hu-HU" sz="2600" b="1" dirty="0" err="1">
+                <a:solidFill>
+                  <a:srgbClr val="263238"/>
+                </a:solidFill>
+                <a:latin typeface="Sorts Mill Goudy" pitchFamily="34" charset="0"/>
+                <a:ea typeface="Sorts Mill Goudy" pitchFamily="34" charset="-122"/>
+                <a:cs typeface="Sorts Mill Goudy" pitchFamily="34" charset="-120"/>
+              </a:rPr>
+              <a:t>ek</a:t>
             </a:r>
             <a:endParaRPr lang="en-US" sz="1600" dirty="0"/>
           </a:p>
@@ -11565,7 +11896,40 @@
                 <a:ea typeface="Sorts Mill Goudy" pitchFamily="34" charset="-122"/>
                 <a:cs typeface="Sorts Mill Goudy" pitchFamily="34" charset="-120"/>
               </a:rPr>
-              <a:t>Kétféle támadási mód — lövés sugárvetéses találattal és közelharc nagyobb sebzéssel</a:t>
+              <a:t>Kétféle </a:t>
+            </a:r>
+            <a:r>
+              <a:rPr lang="en-US" sz="2600" b="1" dirty="0" err="1">
+                <a:solidFill>
+                  <a:srgbClr val="263238"/>
+                </a:solidFill>
+                <a:latin typeface="Sorts Mill Goudy" pitchFamily="34" charset="0"/>
+                <a:ea typeface="Sorts Mill Goudy" pitchFamily="34" charset="-122"/>
+                <a:cs typeface="Sorts Mill Goudy" pitchFamily="34" charset="-120"/>
+              </a:rPr>
+              <a:t>támadási</a:t>
+            </a:r>
+            <a:r>
+              <a:rPr lang="en-US" sz="2600" b="1" dirty="0">
+                <a:solidFill>
+                  <a:srgbClr val="263238"/>
+                </a:solidFill>
+                <a:latin typeface="Sorts Mill Goudy" pitchFamily="34" charset="0"/>
+                <a:ea typeface="Sorts Mill Goudy" pitchFamily="34" charset="-122"/>
+                <a:cs typeface="Sorts Mill Goudy" pitchFamily="34" charset="-120"/>
+              </a:rPr>
+              <a:t> </a:t>
+            </a:r>
+            <a:r>
+              <a:rPr lang="en-US" sz="2600" b="1" dirty="0" err="1">
+                <a:solidFill>
+                  <a:srgbClr val="263238"/>
+                </a:solidFill>
+                <a:latin typeface="Sorts Mill Goudy" pitchFamily="34" charset="0"/>
+                <a:ea typeface="Sorts Mill Goudy" pitchFamily="34" charset="-122"/>
+                <a:cs typeface="Sorts Mill Goudy" pitchFamily="34" charset="-120"/>
+              </a:rPr>
+              <a:t>mód</a:t>
             </a:r>
             <a:endParaRPr lang="en-US" sz="1600" dirty="0"/>
           </a:p>
@@ -11775,7 +12139,51 @@
                 <a:ea typeface="Liter" pitchFamily="34" charset="-122"/>
                 <a:cs typeface="Liter" pitchFamily="34" charset="-120"/>
               </a:rPr>
-              <a:t> bal egérgomb (MOUSEBUTTONDOWN)</a:t>
+              <a:t> </a:t>
+            </a:r>
+            <a:r>
+              <a:rPr lang="en-US" sz="1800" dirty="0" err="1">
+                <a:solidFill>
+                  <a:srgbClr val="333333"/>
+                </a:solidFill>
+                <a:latin typeface="Liter" pitchFamily="34" charset="0"/>
+                <a:ea typeface="Liter" pitchFamily="34" charset="-122"/>
+                <a:cs typeface="Liter" pitchFamily="34" charset="-120"/>
+              </a:rPr>
+              <a:t>bal</a:t>
+            </a:r>
+            <a:r>
+              <a:rPr lang="en-US" sz="1800" dirty="0">
+                <a:solidFill>
+                  <a:srgbClr val="333333"/>
+                </a:solidFill>
+                <a:latin typeface="Liter" pitchFamily="34" charset="0"/>
+                <a:ea typeface="Liter" pitchFamily="34" charset="-122"/>
+                <a:cs typeface="Liter" pitchFamily="34" charset="-120"/>
+              </a:rPr>
+              <a:t> </a:t>
+            </a:r>
+            <a:r>
+              <a:rPr lang="en-US" sz="1800" dirty="0" err="1">
+                <a:solidFill>
+                  <a:srgbClr val="333333"/>
+                </a:solidFill>
+                <a:latin typeface="Liter" pitchFamily="34" charset="0"/>
+                <a:ea typeface="Liter" pitchFamily="34" charset="-122"/>
+                <a:cs typeface="Liter" pitchFamily="34" charset="-120"/>
+              </a:rPr>
+              <a:t>egérgom</a:t>
+            </a:r>
+            <a:r>
+              <a:rPr lang="hu-HU" sz="1800" dirty="0">
+                <a:solidFill>
+                  <a:srgbClr val="333333"/>
+                </a:solidFill>
+                <a:latin typeface="Liter" pitchFamily="34" charset="0"/>
+                <a:ea typeface="Liter" pitchFamily="34" charset="-122"/>
+                <a:cs typeface="Liter" pitchFamily="34" charset="-120"/>
+              </a:rPr>
+              <a:t>b</a:t>
             </a:r>
             <a:endParaRPr lang="en-US" sz="1600" dirty="0"/>
           </a:p>
@@ -11958,7 +12366,18 @@
                 <a:ea typeface="Liter" pitchFamily="34" charset="-122"/>
                 <a:cs typeface="Liter" pitchFamily="34" charset="-120"/>
               </a:rPr>
-              <a:t> F billentyű (KEYDOWN K_f)</a:t>
+              <a:t> F </a:t>
+            </a:r>
+            <a:r>
+              <a:rPr lang="en-US" sz="1800" dirty="0" err="1">
+                <a:solidFill>
+                  <a:srgbClr val="333333"/>
+                </a:solidFill>
+                <a:latin typeface="Liter" pitchFamily="34" charset="0"/>
+                <a:ea typeface="Liter" pitchFamily="34" charset="-122"/>
+                <a:cs typeface="Liter" pitchFamily="34" charset="-120"/>
+              </a:rPr>
+              <a:t>billentyű</a:t>
             </a:r>
             <a:endParaRPr lang="en-US" sz="1600" dirty="0"/>
           </a:p>
@@ -12108,7 +12527,51 @@
                 <a:ea typeface="Liter" pitchFamily="34" charset="-122"/>
                 <a:cs typeface="Liter" pitchFamily="34" charset="-120"/>
               </a:rPr>
-              <a:t> Zöld (&gt;60%), narancssárga (30-60%), piros (&lt;30%).</a:t>
+              <a:t> Zöld, </a:t>
+            </a:r>
+            <a:r>
+              <a:rPr lang="en-US" sz="1800" dirty="0" err="1">
+                <a:solidFill>
+                  <a:srgbClr val="333333"/>
+                </a:solidFill>
+                <a:latin typeface="Liter" pitchFamily="34" charset="0"/>
+                <a:ea typeface="Liter" pitchFamily="34" charset="-122"/>
+                <a:cs typeface="Liter" pitchFamily="34" charset="-120"/>
+              </a:rPr>
+              <a:t>narancssárga</a:t>
+            </a:r>
+            <a:r>
+              <a:rPr lang="en-US" sz="1800" dirty="0">
+                <a:solidFill>
+                  <a:srgbClr val="333333"/>
+                </a:solidFill>
+                <a:latin typeface="Liter" pitchFamily="34" charset="0"/>
+                <a:ea typeface="Liter" pitchFamily="34" charset="-122"/>
+                <a:cs typeface="Liter" pitchFamily="34" charset="-120"/>
+              </a:rPr>
+              <a:t>, </a:t>
+            </a:r>
+            <a:r>
+              <a:rPr lang="en-US" sz="1800" dirty="0" err="1">
+                <a:solidFill>
+                  <a:srgbClr val="333333"/>
+                </a:solidFill>
+                <a:latin typeface="Liter" pitchFamily="34" charset="0"/>
+                <a:ea typeface="Liter" pitchFamily="34" charset="-122"/>
+                <a:cs typeface="Liter" pitchFamily="34" charset="-120"/>
+              </a:rPr>
+              <a:t>piros</a:t>
+            </a:r>
+            <a:r>
+              <a:rPr lang="en-US" sz="1800" dirty="0">
+                <a:solidFill>
+                  <a:srgbClr val="333333"/>
+                </a:solidFill>
+                <a:latin typeface="Liter" pitchFamily="34" charset="0"/>
+                <a:ea typeface="Liter" pitchFamily="34" charset="-122"/>
+                <a:cs typeface="Liter" pitchFamily="34" charset="-120"/>
+              </a:rPr>
+              <a:t>.</a:t>
             </a:r>
             <a:endParaRPr lang="en-US" sz="1600" dirty="0"/>
           </a:p>
@@ -12344,7 +12807,7 @@
               </a:lnSpc>
             </a:pPr>
             <a:r>
-              <a:rPr lang="en-US" sz="2600" b="1" dirty="0">
+              <a:rPr lang="hu-HU" sz="2600" b="1" dirty="0">
                 <a:solidFill>
                   <a:srgbClr val="263238"/>
                 </a:solidFill>
@@ -12352,7 +12815,84 @@
                 <a:ea typeface="Sorts Mill Goudy" pitchFamily="34" charset="-122"/>
                 <a:cs typeface="Sorts Mill Goudy" pitchFamily="34" charset="-120"/>
               </a:rPr>
-              <a:t>Animált ajtórendszer és dinamikus zseblámpa effekt fokozza a horror hangulatot</a:t>
+              <a:t>A</a:t>
+            </a:r>
+            <a:r>
+              <a:rPr lang="en-US" sz="2600" b="1" dirty="0" err="1">
+                <a:solidFill>
+                  <a:srgbClr val="263238"/>
+                </a:solidFill>
+                <a:latin typeface="Sorts Mill Goudy" pitchFamily="34" charset="0"/>
+                <a:ea typeface="Sorts Mill Goudy" pitchFamily="34" charset="-122"/>
+                <a:cs typeface="Sorts Mill Goudy" pitchFamily="34" charset="-120"/>
+              </a:rPr>
+              <a:t>jtórendszer</a:t>
+            </a:r>
+            <a:r>
+              <a:rPr lang="en-US" sz="2600" b="1" dirty="0">
+                <a:solidFill>
+                  <a:srgbClr val="263238"/>
+                </a:solidFill>
+                <a:latin typeface="Sorts Mill Goudy" pitchFamily="34" charset="0"/>
+                <a:ea typeface="Sorts Mill Goudy" pitchFamily="34" charset="-122"/>
+                <a:cs typeface="Sorts Mill Goudy" pitchFamily="34" charset="-120"/>
+              </a:rPr>
+              <a:t> </a:t>
+            </a:r>
+            <a:r>
+              <a:rPr lang="en-US" sz="2600" b="1" dirty="0" err="1">
+                <a:solidFill>
+                  <a:srgbClr val="263238"/>
+                </a:solidFill>
+                <a:latin typeface="Sorts Mill Goudy" pitchFamily="34" charset="0"/>
+                <a:ea typeface="Sorts Mill Goudy" pitchFamily="34" charset="-122"/>
+                <a:cs typeface="Sorts Mill Goudy" pitchFamily="34" charset="-120"/>
+              </a:rPr>
+              <a:t>és</a:t>
+            </a:r>
+            <a:r>
+              <a:rPr lang="en-US" sz="2600" b="1" dirty="0">
+                <a:solidFill>
+                  <a:srgbClr val="263238"/>
+                </a:solidFill>
+                <a:latin typeface="Sorts Mill Goudy" pitchFamily="34" charset="0"/>
+                <a:ea typeface="Sorts Mill Goudy" pitchFamily="34" charset="-122"/>
+                <a:cs typeface="Sorts Mill Goudy" pitchFamily="34" charset="-120"/>
+              </a:rPr>
+              <a:t> </a:t>
+            </a:r>
+            <a:r>
+              <a:rPr lang="en-US" sz="2600" b="1" dirty="0" err="1">
+                <a:solidFill>
+                  <a:srgbClr val="263238"/>
+                </a:solidFill>
+                <a:latin typeface="Sorts Mill Goudy" pitchFamily="34" charset="0"/>
+                <a:ea typeface="Sorts Mill Goudy" pitchFamily="34" charset="-122"/>
+                <a:cs typeface="Sorts Mill Goudy" pitchFamily="34" charset="-120"/>
+              </a:rPr>
+              <a:t>zseblámpa</a:t>
+            </a:r>
+            <a:r>
+              <a:rPr lang="en-US" sz="2600" b="1" dirty="0">
+                <a:solidFill>
+                  <a:srgbClr val="263238"/>
+                </a:solidFill>
+                <a:latin typeface="Sorts Mill Goudy" pitchFamily="34" charset="0"/>
+                <a:ea typeface="Sorts Mill Goudy" pitchFamily="34" charset="-122"/>
+                <a:cs typeface="Sorts Mill Goudy" pitchFamily="34" charset="-120"/>
+              </a:rPr>
+              <a:t> </a:t>
+            </a:r>
+            <a:r>
+              <a:rPr lang="en-US" sz="2600" b="1" dirty="0" err="1">
+                <a:solidFill>
+                  <a:srgbClr val="263238"/>
+                </a:solidFill>
+                <a:latin typeface="Sorts Mill Goudy" pitchFamily="34" charset="0"/>
+                <a:ea typeface="Sorts Mill Goudy" pitchFamily="34" charset="-122"/>
+                <a:cs typeface="Sorts Mill Goudy" pitchFamily="34" charset="-120"/>
+              </a:rPr>
+              <a:t>effekt</a:t>
             </a:r>
             <a:endParaRPr lang="en-US" sz="1600" dirty="0"/>
           </a:p>

</xml_diff>